<commit_message>
latest results, interpretations and validation of social dilemma conditions
</commit_message>
<xml_diff>
--- a/results/presentation/cognitive_tools_supervisor_data_round_7_slides.pptx
+++ b/results/presentation/cognitive_tools_supervisor_data_round_7_slides.pptx
@@ -530,7 +530,7 @@
           <a:lstStyle/>
           <a:p>
             <a:r>
-              <a:t>Purpose: request feedback on a focused question and mechanism, not sell a positive result. The hypothesis is directional and is not established by this pilot. Collective organization means measured population patterns in visibility and extraction behavior; it does not mean conscious coordination. Ecology and search scope are conditions, welfare and inequality are consequences. The design is inspired by Schrama et al. (2025), https://doi.org/10.1016/j.isci.2025.112831, and Oh &amp; Schauf (2025), https://doi.org/10.1038/s41598-025-23634-3. No published figure or model result is reproduced here.</a:t>
+              <a:t>Purpose: obtain supervisor feedback on the clarity of the research questions, hypotheses and project structure. These are the confirmed frozen hypotheses in docs/ideas/ecology-perception-organization.md, not the older pilot hypothesis of a necessary sustainability improvement. H1 is nondirectional. H2 was informed by related work and the pilot. H3 predicts a difference, not necessarily an improvement. Collective organization means measurable population patterns, not conscious coordination. Secondary consequences are resource condition, reserve welfare and accumulated-harvest inequality.</a:t>
             </a:r>
           </a:p>
         </p:txBody>
@@ -600,7 +600,7 @@
           <a:lstStyle/>
           <a:p>
             <a:r>
-              <a:t>Conceptual diagram; arrows summarize the feedback rather than the exact computation sequence. Training order: form state from current ecology and previous source actions; choose extraction; ecological transition; observe current actions through pre-rewiring graph; prediction error; optional rewiring; forecast update using pre-rewiring observation; next-state and Q update. Error is social surprise, not a truth/correctness label or an assessment of source competence. Current-source removal and replacement are random conditional on an observer being triggered. Agents do not move and do not share Q tables. Information arrows source-&gt;observer. Local search uses sources of sources with global fallback. Related work differs: Oh &amp; Schauf use correctness and DeGroot consensus, whereas this model uses surprise and Q-learning.</a:t>
+              <a:t>The schematic describes the feedback, not every implementation step. Agents observe previous source actions alongside local resource/capacity, choose extraction with independent tabular Q-learning, experience resource renewal, compare expected versus observed peer actions and may replace information sources. Surprise selects observers; removed and replacement sources are random conditional on the search rule. Local replacement is sources-of-sources in the information graph, not geographical proximity. Reward is realized harvest. Stationary locations, proportional allocation under scarcity and a 3×3 state representation restrict the behavioral mechanism. The review found 97.1% scarce-state occupancy in fresh-reset evaluation, 99.7% in continuation. These are diagnostics, not causal proof of a representation failure.</a:t>
             </a:r>
           </a:p>
         </p:txBody>
@@ -670,7 +670,7 @@
           <a:lstStyle/>
           <a:p>
             <a:r>
-              <a:t>Pilot v1: 9 runs x 3 scenarios x 2 populations x 10 replicates = 540 training conditions. Same seed family, ecological and learning settings; adaptive mu=.10, threshold=.25, every 50 steps, social k=4, BA m=2; theta 0,.25,1. R0 event counts match the paired adaptive run at each scenario/population/replicate/time checkpoint. SHA-256 source schedules verified. Primary analysis uses q_learning/fresh_reset/terminal graph, not continuation or reset-initial graph. Capacity maps show seed 42, replicate 0, constructed from the frozen scenario code; maps are illustrative, with shared viridis scale 0-1. Source files: pilot_v1_*/config.json; original commit b0340b10dd33499a714af5c22ab124b05f680a3a, clean. S2 varies attention capacity as well as visibility.</a:t>
+              <a:t>Full campaign ecology_perception_parallel_v1, source commit 2ac3a887f271874d9ff71726a3d0ed9e83601efc. Nine treatments: B0, S1, S2, R1/R2/R3 and their three matched R0 controls. Three ecologies, N=64, 100 replicates each, 5000 training and 1000 evaluation steps. Primary perception and organization outcomes average the 20 recorded checkpoints in 4000&lt;t≤5000 within replicate. Secondary outcomes use fresh-reset evaluation with frozen policies and terminal networks. R0 matches event counts and search scope, identifying observer selection conditional on the adaptive schedule. S2 changes attention capacity too. Maps are illustrative seed-42 capacity maps from the same scenario definitions, not observations from the full-run replicates. Split bundles changes in capacity, regeneration, equilibrium and spatial arrangement.</a:t>
             </a:r>
           </a:p>
         </p:txBody>
@@ -740,7 +740,7 @@
           <a:lstStyle/>
           <a:p>
             <a:r>
-              <a:t>This slide operationalizes collective organization as visibility concentration and prevalence of low-extraction actions. All six rewiring treatments shown, all three ecologies, N=64. Solid=adaptive; dashed=its event-count-matched R0; blue=local, teal=mixed, ochre=global. Each line is a mean of 10 independent replicate trajectories; no smoothing and no inference from line separation. The full N=32 figure is supplied to avoid presenting one population as the whole pilot. Local search visibly concentrates attention, and R0 often tracks the same pattern. This is not evidence that the error trigger uniquely organizes the population. Low extraction remains below one half in the displayed mean trajectories. Source: pilot_v1_*/data/training_timeseries.csv. Design rationale: Oh &amp; Schauf (2025), Fig. 6 separates structure from performance over time; our metrics and mechanism differ. https://pmc.ncbi.nlm.nih.gov/articles/PMC12618610/</a:t>
+              <a:t>Figure uses primary_window_summary.csv, all eight social treatments and all ecologies. Error is the absolute difference between observed low-extraction fraction and prevalence among the other 63 agents. Mismatch excludes ties; tied comparisons are shown separately. S2−S1 error is +4.07 to +4.26 pp, but attention varies. Across ecology/scope pairs, adaptive−matched mismatch is −1.35 to −2.16 pp; all nine pointwise intervals exclude zero. MAE improves by 0.095 to 0.443 pp; seven of nine intervals exclude zero. Tie rates generally decrease too. The post-hoc exact hypergeometric four-peer baseline is 17.55–17.81 pp; fixed-attention observed-minus-baseline means range −0.273 to +0.210 pp. This diagnostic conditions on current population actions and is not a counterfactual training run. It excludes variable-attention S2. Reference: Lerman et al., The Majority Illusion in Social Networks, https://arxiv.org/abs/1506.03022. Complete paired results and sampling figures are in results/review/full_run_2026-09-29/.</a:t>
             </a:r>
           </a:p>
         </p:txBody>
@@ -810,7 +810,7 @@
           <a:lstStyle/>
           <a:p>
             <a:r>
-              <a:t>Outcome is the replicate-level mean resource/capacity during 1000-step fresh-reset evaluation with frozen terminal graphs and frozen Q policies. Differences are adaptive minus its own exact R0, paired by scenario, population, and replicate. Three panels share the same x range [-5,+5] percentage points. Circle/open=N32; square/filled=N64; row labels are explicit. All 18 comparisons shown. 15 intervals cross zero; this is uncertainty, not proof of equivalence. Three intervals exclude zero: local/split/N32 negative, mixed/split/N64 positive, global/split/N32 positive. They are exploratory, unadjusted intervals, not three confirmed discoveries. All point estimates span -2.105 to +1.497 pp. Underlying means and bootstrap intervals were independently reproduced from raw records. Archive analysis seed 1729, 2000 percentile-bootstrap resamples. Source: paired_adaptive_minus_r0_summary.csv. Replicate outcome distributions are supplied separately, following the distribution-preserving principle illustrated by Schrama et al. (2025), Fig. 2, https://pmc.ncbi.nlm.nih.gov/articles/PMC12226385/. This pilot is not evidence of bistability.</a:t>
+              <a:t>Figure uses primary_window_summary.csv. Display all nine treatments; B0 has no observation network and therefore no visibility-Gini point. Adaptive local−global visibility Gini is +0.116 to +0.123 across ecologies; matched random local−global is +0.114 to +0.123. This supports the scope prediction, not attribution of concentration to the surprise trigger. All nine adaptive−matched low-extraction intervals and visibility-Gini intervals include zero. This is not an equivalence conclusion. All figures use 100 independent replicates per condition, not agents as independent samples. Bootstrap intervals are pointwise percentile intervals from 5000 resamples, without multiplicity adjustment. Zoomed axes are deliberate.</a:t>
             </a:r>
           </a:p>
         </p:txBody>
@@ -880,7 +880,7 @@
           <a:lstStyle/>
           <a:p>
             <a:r>
-              <a:t>This is a transparent close-up of split_high_low, the ecology where the resource effects change sign; all six scope/population comparisons are shown, not only the favorable one. All-ecology welfare and final-wealth-Gini figures are supplied in figures/. Reserve welfare is energy/capacity, averaged during evaluation; wealth Gini is measured at the final evaluation step. R2/N64 resource effect .010238 (95% CI .004494,.016077), reserve welfare .016240 (.003325,.028887), final wealth Gini .001631 (-.008370,.011563). Percentage points are differences of 0-1 fractions, not relative percent changes. Inequality uses Gini units; negative is less unequal. Outcome dimensions need separate interpretations; the intervals are exploratory and not multiplicity-adjusted. See data/paired_summary.csv and data_audit.json.</a:t>
+              <a:t>Figure uses outcome_summary.csv, all nine treatments and all three ecologies. Across eight social treatments, split−uniform welfare is −9.49 to −11.92 percentage points and wealth Gini +0.169 to +0.175. These are ranges of treatment-specific effects, not confidence intervals or pooled effects. Resource metric is mean local R/K, not total stock; a larger normalized fraction does not imply a richer ecology. R0 paired effects: all nine wealth-Gini intervals include zero, eight of nine welfare and eight of nine resource intervals include zero. The isolated positive intervals are unadjusted and do not establish broad benefit. The 72.3% fresh-reset versus 26.2% continuation welfare diagnostic equally weights 27 condition means. Reset restores ecology and full initial energy; it is not a pure energy intervention. Neither 1000-step evaluation establishes long-run sustainability. Existing values/paired means were independently checked against raw tables in the review.</a:t>
             </a:r>
           </a:p>
         </p:txBody>
@@ -950,7 +950,7 @@
           <a:lstStyle/>
           <a:p>
             <a:r>
-              <a:t>Closing discussion, not a claim of confirmation. Keep project scope to renewable ecology, independent extraction learning, limited peer observation, and rewiring. The pilot supports a structural search-scope pattern but does not establish an adaptive sustainability advantage. Ask the supervisor to sharpen a falsifiable prediction about population-level behavior/visibility and its relationship to resources. Avoid scope expansion into technology, inheritance, trade, misinformation, or ecological shocks in this seven-slide argument. Larger confirmatory runs should follow a fixed hypothesis and declared primary comparison, not selection of the most favorable pilot cell. Full source and figure-design rationale: figure_review.md; reproducible build: build_data_round.py; audit: data_audit.json.</a:t>
+              <a:t>Close by separating conclusions from proposed future work. No migration or new simulation has been undertaken. Prospective hypothesis: information improves outcomes when it predicts ecological consequences relevant to the observer; population representativeness alone may be insufficient. A constrained option is one Commons Harvest substrate, one learner, two productivity-matched arrangements and informative versus shuffled social signals with equal attention. Define behavior over a fixed opportunity-aware window: inactivity in a movement/harvesting environment is not automatically cooperation. SocialJax offers GPU-oriented Harvest and IPPO/MAPPO baselines: https://github.com/cooperativex/SocialJax. Melting Pot is the benchmark-provenance alternative: https://github.com/google-deepmind/meltingpot. The older sequential_social_dilemma_games repository explicitly recommends Melting Pot. These are candidates, not locally benchmarked migration commitments. Full review: docs/reviews/full-run-review-2026-09-29.md. Ask the supervisor to select the scientific direction before adding mechanisms.</a:t>
             </a:r>
           </a:p>
         </p:txBody>
@@ -3954,7 +3954,7 @@
               <a:spcAft>
                 <a:spcPts val="400"/>
               </a:spcAft>
-              <a:defRPr sz="4050" b="1">
+              <a:defRPr sz="3800" b="1">
                 <a:solidFill>
                   <a:srgbClr val="111111"/>
                 </a:solidFill>
@@ -3962,7 +3962,8 @@
               </a:defRPr>
             </a:pPr>
             <a:r>
-              <a:t>How do local observations become collective outcomes?</a:t>
+              <a:rPr sz="3800"/>
+              <a:t>How does ecology shape perception and collective organization?</a:t>
             </a:r>
           </a:p>
         </p:txBody>
@@ -4001,7 +4002,7 @@
               </a:defRPr>
             </a:pPr>
             <a:r>
-              <a:t>COGNITIVE TOOLS  /  SUPERVISOR DATA ROUND  /  PILOT v1</a:t>
+              <a:t>COGNITIVE TOOLS  /  SUPERVISOR DATA ROUND  /  FULL RUN · SEPTEMBER 2026</a:t>
             </a:r>
           </a:p>
         </p:txBody>
@@ -4071,7 +4072,7 @@
               <a:spcAft>
                 <a:spcPts val="400"/>
               </a:spcAft>
-              <a:defRPr sz="3700" b="1">
+              <a:defRPr sz="3100" b="1">
                 <a:solidFill>
                   <a:srgbClr val="111111"/>
                 </a:solidFill>
@@ -4079,7 +4080,8 @@
               </a:defRPr>
             </a:pPr>
             <a:r>
-              <a:t>Can changing whom agents observe produce population-level</a:t>
+              <a:rPr sz="3100"/>
+              <a:t>RQ1: When do local observations misrepresent population behavior?</a:t>
             </a:r>
           </a:p>
           <a:p>
@@ -4087,7 +4089,7 @@
               <a:spcAft>
                 <a:spcPts val="400"/>
               </a:spcAft>
-              <a:defRPr sz="3700" b="1">
+              <a:defRPr sz="3100" b="1">
                 <a:solidFill>
                   <a:srgbClr val="111111"/>
                 </a:solidFill>
@@ -4095,7 +4097,8 @@
               </a:defRPr>
             </a:pPr>
             <a:r>
-              <a:t>patterns that sustain a shared renewable resource?</a:t>
+              <a:rPr sz="3100"/>
+              <a:t>RQ2: How do ecology and observation rules organize the population?</a:t>
             </a:r>
           </a:p>
         </p:txBody>
@@ -4214,7 +4217,7 @@
               <a:spcAft>
                 <a:spcPts val="400"/>
               </a:spcAft>
-              <a:defRPr sz="3000" b="1">
+              <a:defRPr sz="2600" b="1">
                 <a:solidFill>
                   <a:srgbClr val="111111"/>
                 </a:solidFill>
@@ -4222,7 +4225,8 @@
               </a:defRPr>
             </a:pPr>
             <a:r>
-              <a:t>Individual observations</a:t>
+              <a:rPr sz="2600"/>
+              <a:t>Local perception</a:t>
             </a:r>
           </a:p>
         </p:txBody>
@@ -4261,7 +4265,7 @@
               </a:defRPr>
             </a:pPr>
             <a:r>
-              <a:t>What do my selected</a:t>
+              <a:t>What do selected peers do?</a:t>
             </a:r>
           </a:p>
           <a:p>
@@ -4277,7 +4281,7 @@
               </a:defRPr>
             </a:pPr>
             <a:r>
-              <a:t>information sources do?</a:t>
+              <a:t>How representative is that view?</a:t>
             </a:r>
           </a:p>
         </p:txBody>
@@ -4396,7 +4400,7 @@
               <a:spcAft>
                 <a:spcPts val="400"/>
               </a:spcAft>
-              <a:defRPr sz="3000" b="1">
+              <a:defRPr sz="2600" b="1">
                 <a:solidFill>
                   <a:srgbClr val="111111"/>
                 </a:solidFill>
@@ -4404,7 +4408,8 @@
               </a:defRPr>
             </a:pPr>
             <a:r>
-              <a:t>Population-level patterns</a:t>
+              <a:rPr sz="2600"/>
+              <a:t>Collective organization</a:t>
             </a:r>
           </a:p>
         </p:txBody>
@@ -4578,7 +4583,7 @@
               <a:spcAft>
                 <a:spcPts val="400"/>
               </a:spcAft>
-              <a:defRPr sz="3000" b="1">
+              <a:defRPr sz="2600" b="1">
                 <a:solidFill>
                   <a:srgbClr val="111111"/>
                 </a:solidFill>
@@ -4586,7 +4591,8 @@
               </a:defRPr>
             </a:pPr>
             <a:r>
-              <a:t>Collective outcomes</a:t>
+              <a:rPr sz="2600"/>
+              <a:t>Consequences</a:t>
             </a:r>
           </a:p>
         </p:txBody>
@@ -4625,7 +4631,7 @@
               </a:defRPr>
             </a:pPr>
             <a:r>
-              <a:t>Resource sustainability</a:t>
+              <a:t>Resource condition</a:t>
             </a:r>
           </a:p>
           <a:p>
@@ -4727,7 +4733,7 @@
         <p:spPr>
           <a:xfrm>
             <a:off x="914400" y="6995160"/>
-            <a:ext cx="2286000" cy="548640"/>
+            <a:ext cx="5486400" cy="548640"/>
           </a:xfrm>
           <a:prstGeom prst="rect">
             <a:avLst/>
@@ -4752,7 +4758,8 @@
               </a:defRPr>
             </a:pPr>
             <a:r>
-              <a:t>HYPOTHESIS</a:t>
+              <a:rPr sz="2100"/>
+              <a:t>FROZEN HYPOTHESES</a:t>
             </a:r>
           </a:p>
         </p:txBody>
@@ -4783,7 +4790,7 @@
               <a:spcAft>
                 <a:spcPts val="400"/>
               </a:spcAft>
-              <a:defRPr sz="3000" b="0">
+              <a:defRPr sz="2700" b="0">
                 <a:solidFill>
                   <a:srgbClr val="111111"/>
                 </a:solidFill>
@@ -4791,7 +4798,8 @@
               </a:defRPr>
             </a:pPr>
             <a:r>
-              <a:t>Prediction-error-driven rewiring produces patterns that improve</a:t>
+              <a:rPr sz="2700"/>
+              <a:t>H1: perception varies with ecology. H2: local search concentrates visibility.</a:t>
             </a:r>
           </a:p>
           <a:p>
@@ -4799,7 +4807,7 @@
               <a:spcAft>
                 <a:spcPts val="400"/>
               </a:spcAft>
-              <a:defRPr sz="3000" b="0">
+              <a:defRPr sz="2700" b="0">
                 <a:solidFill>
                   <a:srgbClr val="111111"/>
                 </a:solidFill>
@@ -4807,7 +4815,8 @@
               </a:defRPr>
             </a:pPr>
             <a:r>
-              <a:t>sustainability beyond the same amount of random network turnover.</a:t>
+              <a:rPr sz="2700"/>
+              <a:t>H3: adaptive selection changes perception relative to matched random turnover.</a:t>
             </a:r>
           </a:p>
         </p:txBody>
@@ -4864,7 +4873,7 @@
               <a:spcAft>
                 <a:spcPts val="400"/>
               </a:spcAft>
-              <a:defRPr sz="4050" b="1">
+              <a:defRPr sz="3800" b="1">
                 <a:solidFill>
                   <a:srgbClr val="111111"/>
                 </a:solidFill>
@@ -4872,7 +4881,8 @@
               </a:defRPr>
             </a:pPr>
             <a:r>
-              <a:t>One feedback loop connects agents, networks, and ecology</a:t>
+              <a:rPr sz="3800"/>
+              <a:t>Population information feeds decisions about local resources</a:t>
             </a:r>
           </a:p>
         </p:txBody>
@@ -4911,7 +4921,7 @@
               </a:defRPr>
             </a:pPr>
             <a:r>
-              <a:t>Agents stay in place. Information links can change; resources do not travel along them.</a:t>
+              <a:t>Agents stay in place; information links change. Population accuracy may not imply local usefulness.</a:t>
             </a:r>
           </a:p>
         </p:txBody>
@@ -4950,7 +4960,7 @@
               </a:defRPr>
             </a:pPr>
             <a:r>
-              <a:t>COGNITIVE TOOLS  /  SUPERVISOR DATA ROUND  /  PILOT v1</a:t>
+              <a:t>COGNITIVE TOOLS  /  SUPERVISOR DATA ROUND  /  FULL RUN · SEPTEMBER 2026</a:t>
             </a:r>
           </a:p>
         </p:txBody>
@@ -5578,7 +5588,7 @@
               <a:spcAft>
                 <a:spcPts val="400"/>
               </a:spcAft>
-              <a:defRPr sz="3000" b="1">
+              <a:defRPr sz="2600" b="1">
                 <a:solidFill>
                   <a:srgbClr val="111111"/>
                 </a:solidFill>
@@ -5586,6 +5596,7 @@
               </a:defRPr>
             </a:pPr>
             <a:r>
+              <a:rPr sz="2600"/>
               <a:t>Learn extraction</a:t>
             </a:r>
           </a:p>
@@ -5760,7 +5771,7 @@
               <a:spcAft>
                 <a:spcPts val="400"/>
               </a:spcAft>
-              <a:defRPr sz="3000" b="1">
+              <a:defRPr sz="2600" b="1">
                 <a:solidFill>
                   <a:srgbClr val="111111"/>
                 </a:solidFill>
@@ -5768,6 +5779,7 @@
               </a:defRPr>
             </a:pPr>
             <a:r>
+              <a:rPr sz="2600"/>
               <a:t>Resource renewal</a:t>
             </a:r>
           </a:p>
@@ -5942,7 +5954,7 @@
               <a:spcAft>
                 <a:spcPts val="400"/>
               </a:spcAft>
-              <a:defRPr sz="3000" b="1">
+              <a:defRPr sz="2600" b="1">
                 <a:solidFill>
                   <a:srgbClr val="111111"/>
                 </a:solidFill>
@@ -5950,6 +5962,7 @@
               </a:defRPr>
             </a:pPr>
             <a:r>
+              <a:rPr sz="2600"/>
               <a:t>Predict and compare</a:t>
             </a:r>
           </a:p>
@@ -6124,7 +6137,7 @@
               <a:spcAft>
                 <a:spcPts val="400"/>
               </a:spcAft>
-              <a:defRPr sz="3000" b="1">
+              <a:defRPr sz="2600" b="1">
                 <a:solidFill>
                   <a:srgbClr val="111111"/>
                 </a:solidFill>
@@ -6132,6 +6145,7 @@
               </a:defRPr>
             </a:pPr>
             <a:r>
+              <a:rPr sz="2600"/>
               <a:t>Replace a source</a:t>
             </a:r>
           </a:p>
@@ -6434,7 +6448,7 @@
               <a:spcAft>
                 <a:spcPts val="400"/>
               </a:spcAft>
-              <a:defRPr sz="2300" b="1">
+              <a:defRPr sz="2100" b="1">
                 <a:solidFill>
                   <a:srgbClr val="111111"/>
                 </a:solidFill>
@@ -6442,7 +6456,8 @@
               </a:defRPr>
             </a:pPr>
             <a:r>
-              <a:t>Reward = own realized harvest. Sustainability is measured, not rewarded.</a:t>
+              <a:rPr sz="2100"/>
+              <a:t>Reward = own harvest. Welfare is measured separately; it does not enter the reward.</a:t>
             </a:r>
           </a:p>
         </p:txBody>
@@ -6499,7 +6514,7 @@
               <a:spcAft>
                 <a:spcPts val="400"/>
               </a:spcAft>
-              <a:defRPr sz="4050" b="1">
+              <a:defRPr sz="3800" b="1">
                 <a:solidFill>
                   <a:srgbClr val="111111"/>
                 </a:solidFill>
@@ -6507,7 +6522,8 @@
               </a:defRPr>
             </a:pPr>
             <a:r>
-              <a:t>The key test holds the amount of rewiring constant</a:t>
+              <a:rPr sz="3800"/>
+              <a:t>The full run separates ecology, search scope and observer selection</a:t>
             </a:r>
           </a:p>
         </p:txBody>
@@ -6546,7 +6562,7 @@
               </a:defRPr>
             </a:pPr>
             <a:r>
-              <a:t>Adaptive rewiring versus matched random turnover, within the same ecological condition.</a:t>
+              <a:t>27 conditions × 100 replicates = 2,700 condition-replicates · 64 agents per population</a:t>
             </a:r>
           </a:p>
         </p:txBody>
@@ -6585,7 +6601,7 @@
               </a:defRPr>
             </a:pPr>
             <a:r>
-              <a:t>COGNITIVE TOOLS  /  SUPERVISOR DATA ROUND  /  PILOT v1</a:t>
+              <a:t>COGNITIVE TOOLS  /  SUPERVISOR DATA ROUND  /  FULL RUN · SEPTEMBER 2026</a:t>
             </a:r>
           </a:p>
         </p:txBody>
@@ -6897,7 +6913,7 @@
               </a:defRPr>
             </a:pPr>
             <a:r>
-              <a:t>Fixed network with uneven visibility</a:t>
+              <a:t>Uneven visibility + varying attention</a:t>
             </a:r>
           </a:p>
         </p:txBody>
@@ -7035,7 +7051,7 @@
               </a:defRPr>
             </a:pPr>
             <a:r>
-              <a:t>Same event counts at every checkpoint</a:t>
+              <a:t>Same rewiring event counts and scope</a:t>
             </a:r>
           </a:p>
           <a:p>
@@ -7051,7 +7067,7 @@
               </a:defRPr>
             </a:pPr>
             <a:r>
-              <a:t>Different rule for which observers rewire</a:t>
+              <a:t>Different selection of observers</a:t>
             </a:r>
           </a:p>
         </p:txBody>
@@ -7303,7 +7319,7 @@
               </a:defRPr>
             </a:pPr>
             <a:r>
-              <a:t>Capacity maps · replicate 0 · common scale 0–1</a:t>
+              <a:t>Illustrative capacity maps · common scale 0–1</a:t>
             </a:r>
           </a:p>
         </p:txBody>
@@ -7334,7 +7350,7 @@
               <a:spcAft>
                 <a:spcPts val="400"/>
               </a:spcAft>
-              <a:defRPr sz="2700" b="0">
+              <a:defRPr sz="2500" b="0">
                 <a:solidFill>
                   <a:srgbClr val="111111"/>
                 </a:solidFill>
@@ -7342,7 +7358,8 @@
               </a:defRPr>
             </a:pPr>
             <a:r>
-              <a:t>3 ecologies × 2 populations (32, 64)</a:t>
+              <a:rPr sz="2500"/>
+              <a:t>3 ecologies × 9 observation rules</a:t>
             </a:r>
           </a:p>
           <a:p>
@@ -7350,7 +7367,7 @@
               <a:spcAft>
                 <a:spcPts val="400"/>
               </a:spcAft>
-              <a:defRPr sz="2700" b="0">
+              <a:defRPr sz="2500" b="0">
                 <a:solidFill>
                   <a:srgbClr val="111111"/>
                 </a:solidFill>
@@ -7358,7 +7375,8 @@
               </a:defRPr>
             </a:pPr>
             <a:r>
-              <a:t>10 replicates per condition</a:t>
+              <a:rPr sz="2500"/>
+              <a:t>100 replicates per condition</a:t>
             </a:r>
           </a:p>
           <a:p>
@@ -7366,7 +7384,7 @@
               <a:spcAft>
                 <a:spcPts val="400"/>
               </a:spcAft>
-              <a:defRPr sz="2700" b="0">
+              <a:defRPr sz="2500" b="0">
                 <a:solidFill>
                   <a:srgbClr val="111111"/>
                 </a:solidFill>
@@ -7374,6 +7392,7 @@
               </a:defRPr>
             </a:pPr>
             <a:r>
+              <a:rPr sz="2500"/>
               <a:t>5,000 training + 1,000 evaluation steps</a:t>
             </a:r>
           </a:p>
@@ -7382,7 +7401,7 @@
               <a:spcAft>
                 <a:spcPts val="400"/>
               </a:spcAft>
-              <a:defRPr sz="2700" b="0">
+              <a:defRPr sz="2500" b="0">
                 <a:solidFill>
                   <a:srgbClr val="111111"/>
                 </a:solidFill>
@@ -7390,7 +7409,8 @@
               </a:defRPr>
             </a:pPr>
             <a:r>
-              <a:t>Fresh ecology; learned policies and graphs frozen</a:t>
+              <a:rPr sz="2500"/>
+              <a:t>Outcomes: fresh reset, frozen policies + graphs</a:t>
             </a:r>
           </a:p>
         </p:txBody>
@@ -7447,7 +7467,7 @@
               <a:spcAft>
                 <a:spcPts val="400"/>
               </a:spcAft>
-              <a:defRPr sz="4050" b="1">
+              <a:defRPr sz="3800" b="1">
                 <a:solidFill>
                   <a:srgbClr val="111111"/>
                 </a:solidFill>
@@ -7455,7 +7475,8 @@
               </a:defRPr>
             </a:pPr>
             <a:r>
-              <a:t>Local search concentrates attention—even with random turnover</a:t>
+              <a:rPr sz="3800"/>
+              <a:t>Observation rules change perception; ecology differences are small</a:t>
             </a:r>
           </a:p>
         </p:txBody>
@@ -7494,7 +7515,7 @@
               </a:defRPr>
             </a:pPr>
             <a:r>
-              <a:t>Population-level patterns during training · N = 64 · all three ecologies</a:t>
+              <a:t>Final 1,000 training steps · all eight social treatments · means and 95% bootstrap intervals</a:t>
             </a:r>
           </a:p>
         </p:txBody>
@@ -7533,7 +7554,7 @@
               </a:defRPr>
             </a:pPr>
             <a:r>
-              <a:t>COGNITIVE TOOLS  /  SUPERVISOR DATA ROUND  /  PILOT v1</a:t>
+              <a:t>COGNITIVE TOOLS  /  SUPERVISOR DATA ROUND  /  FULL RUN · SEPTEMBER 2026</a:t>
             </a:r>
           </a:p>
         </p:txBody>
@@ -7577,108 +7598,110 @@
           </a:p>
         </p:txBody>
       </p:sp>
+      <p:sp>
+        <p:nvSpPr>
+          <p:cNvPr id="7" name="TextBox 6"/>
+          <p:cNvSpPr txBox="1"/>
+          <p:nvPr/>
+        </p:nvSpPr>
+        <p:spPr>
+          <a:xfrm>
+            <a:off x="914400" y="8458200"/>
+            <a:ext cx="16459200" cy="594360"/>
+          </a:xfrm>
+          <a:prstGeom prst="rect">
+            <a:avLst/>
+          </a:prstGeom>
+          <a:noFill/>
+        </p:spPr>
+        <p:txBody>
+          <a:bodyPr wrap="square" lIns="0" rIns="0" tIns="0" bIns="0">
+            <a:spAutoFit/>
+          </a:bodyPr>
+          <a:lstStyle/>
+          <a:p>
+            <a:pPr algn="l">
+              <a:spcAft>
+                <a:spcPts val="400"/>
+              </a:spcAft>
+              <a:defRPr sz="2700" b="1">
+                <a:solidFill>
+                  <a:srgbClr val="111111"/>
+                </a:solidFill>
+                <a:latin typeface="Arial"/>
+              </a:defRPr>
+            </a:pPr>
+            <a:r>
+              <a:rPr sz="2700"/>
+              <a:t>Adaptive selection lowers non-tie mismatch by 1.35–2.16 pp versus matched turnover.</a:t>
+            </a:r>
+          </a:p>
+        </p:txBody>
+      </p:sp>
+      <p:sp>
+        <p:nvSpPr>
+          <p:cNvPr id="8" name="TextBox 7"/>
+          <p:cNvSpPr txBox="1"/>
+          <p:nvPr/>
+        </p:nvSpPr>
+        <p:spPr>
+          <a:xfrm>
+            <a:off x="914400" y="9070848"/>
+            <a:ext cx="16459200" cy="365760"/>
+          </a:xfrm>
+          <a:prstGeom prst="rect">
+            <a:avLst/>
+          </a:prstGeom>
+          <a:noFill/>
+        </p:spPr>
+        <p:txBody>
+          <a:bodyPr wrap="square" lIns="0" rIns="0" tIns="0" bIns="0">
+            <a:spAutoFit/>
+          </a:bodyPr>
+          <a:lstStyle/>
+          <a:p>
+            <a:pPr algn="l">
+              <a:spcAft>
+                <a:spcPts val="400"/>
+              </a:spcAft>
+              <a:defRPr sz="1900" b="0">
+                <a:solidFill>
+                  <a:srgbClr val="666666"/>
+                </a:solidFill>
+                <a:latin typeface="Arial"/>
+              </a:defRPr>
+            </a:pPr>
+            <a:r>
+              <a:rPr sz="1900"/>
+              <a:t>Raw error includes sampling: four random peers already imply 17.5–17.8 pp MAE. S2 also varies attention capacity.</a:t>
+            </a:r>
+          </a:p>
+        </p:txBody>
+      </p:sp>
       <p:pic>
         <p:nvPicPr>
-          <p:cNvPr id="6" name="Picture 5" descr="organization_N64.png"/>
+          <p:cNvPr id="9" name="Picture 8" descr="perception.png"/>
           <p:cNvPicPr>
             <a:picLocks noChangeAspect="1"/>
           </p:cNvPicPr>
           <p:nvPr/>
         </p:nvPicPr>
         <p:blipFill>
-          <a:blip r:embed="rId2"/>
+          <a:blip r:embed="rId4"/>
           <a:stretch>
             <a:fillRect/>
           </a:stretch>
         </p:blipFill>
         <p:spPr>
           <a:xfrm>
-            <a:off x="1577064" y="2331720"/>
-            <a:ext cx="15133871" cy="5989320"/>
+            <a:off x="457200" y="2377440"/>
+            <a:ext cx="17373600" cy="6190488"/>
           </a:xfrm>
           <a:prstGeom prst="rect">
             <a:avLst/>
           </a:prstGeom>
         </p:spPr>
       </p:pic>
-      <p:sp>
-        <p:nvSpPr>
-          <p:cNvPr id="7" name="TextBox 6"/>
-          <p:cNvSpPr txBox="1"/>
-          <p:nvPr/>
-        </p:nvSpPr>
-        <p:spPr>
-          <a:xfrm>
-            <a:off x="914400" y="8531352"/>
-            <a:ext cx="16459200" cy="594360"/>
-          </a:xfrm>
-          <a:prstGeom prst="rect">
-            <a:avLst/>
-          </a:prstGeom>
-          <a:noFill/>
-        </p:spPr>
-        <p:txBody>
-          <a:bodyPr wrap="square" lIns="0" rIns="0" tIns="0" bIns="0">
-            <a:spAutoFit/>
-          </a:bodyPr>
-          <a:lstStyle/>
-          <a:p>
-            <a:pPr algn="l">
-              <a:spcAft>
-                <a:spcPts val="400"/>
-              </a:spcAft>
-              <a:defRPr sz="2900" b="1">
-                <a:solidFill>
-                  <a:srgbClr val="111111"/>
-                </a:solidFill>
-                <a:latin typeface="Arial"/>
-              </a:defRPr>
-            </a:pPr>
-            <a:r>
-              <a:t>Organization appears in both adaptive and matched-random networks.</a:t>
-            </a:r>
-          </a:p>
-        </p:txBody>
-      </p:sp>
-      <p:sp>
-        <p:nvSpPr>
-          <p:cNvPr id="8" name="TextBox 7"/>
-          <p:cNvSpPr txBox="1"/>
-          <p:nvPr/>
-        </p:nvSpPr>
-        <p:spPr>
-          <a:xfrm>
-            <a:off x="914400" y="9198864"/>
-            <a:ext cx="16459200" cy="365760"/>
-          </a:xfrm>
-          <a:prstGeom prst="rect">
-            <a:avLst/>
-          </a:prstGeom>
-          <a:noFill/>
-        </p:spPr>
-        <p:txBody>
-          <a:bodyPr wrap="square" lIns="0" rIns="0" tIns="0" bIns="0">
-            <a:spAutoFit/>
-          </a:bodyPr>
-          <a:lstStyle/>
-          <a:p>
-            <a:pPr algn="l">
-              <a:spcAft>
-                <a:spcPts val="400"/>
-              </a:spcAft>
-              <a:defRPr sz="1900" b="0">
-                <a:solidFill>
-                  <a:srgbClr val="666666"/>
-                </a:solidFill>
-                <a:latin typeface="Arial"/>
-              </a:defRPr>
-            </a:pPr>
-            <a:r>
-              <a:t>Lines: means of 10 replicates, unsmoothed; descriptive trends, not uncertainty intervals. N=32 companion supplied.</a:t>
-            </a:r>
-          </a:p>
-        </p:txBody>
-      </p:sp>
     </p:spTree>
   </p:cSld>
   <p:clrMapOvr>
@@ -7731,7 +7754,7 @@
               <a:spcAft>
                 <a:spcPts val="400"/>
               </a:spcAft>
-              <a:defRPr sz="4050" b="1">
+              <a:defRPr sz="3800" b="1">
                 <a:solidFill>
                   <a:srgbClr val="111111"/>
                 </a:solidFill>
@@ -7739,7 +7762,8 @@
               </a:defRPr>
             </a:pPr>
             <a:r>
-              <a:t>Adaptive rewiring has no clear general sustainability advantage</a:t>
+              <a:rPr sz="3800"/>
+              <a:t>Local search concentrates visibility, even under random turnover</a:t>
             </a:r>
           </a:p>
         </p:txBody>
@@ -7778,7 +7802,7 @@
               </a:defRPr>
             </a:pPr>
             <a:r>
-              <a:t>Difference from matched random turnover · every ecology, search scope, and population</a:t>
+              <a:t>Collective organization = visibility concentration and prevalence of low-extraction behavior</a:t>
             </a:r>
           </a:p>
         </p:txBody>
@@ -7817,7 +7841,7 @@
               </a:defRPr>
             </a:pPr>
             <a:r>
-              <a:t>COGNITIVE TOOLS  /  SUPERVISOR DATA ROUND  /  PILOT v1</a:t>
+              <a:t>COGNITIVE TOOLS  /  SUPERVISOR DATA ROUND  /  FULL RUN · SEPTEMBER 2026</a:t>
             </a:r>
           </a:p>
         </p:txBody>
@@ -7861,124 +7885,127 @@
           </a:p>
         </p:txBody>
       </p:sp>
+      <p:sp>
+        <p:nvSpPr>
+          <p:cNvPr id="7" name="TextBox 6"/>
+          <p:cNvSpPr txBox="1"/>
+          <p:nvPr/>
+        </p:nvSpPr>
+        <p:spPr>
+          <a:xfrm>
+            <a:off x="914400" y="8458200"/>
+            <a:ext cx="16459200" cy="594360"/>
+          </a:xfrm>
+          <a:prstGeom prst="rect">
+            <a:avLst/>
+          </a:prstGeom>
+          <a:noFill/>
+        </p:spPr>
+        <p:txBody>
+          <a:bodyPr wrap="square" lIns="0" rIns="0" tIns="0" bIns="0">
+            <a:spAutoFit/>
+          </a:bodyPr>
+          <a:lstStyle/>
+          <a:p>
+            <a:pPr algn="l">
+              <a:spcAft>
+                <a:spcPts val="400"/>
+              </a:spcAft>
+              <a:defRPr sz="2700" b="1">
+                <a:solidFill>
+                  <a:srgbClr val="111111"/>
+                </a:solidFill>
+                <a:latin typeface="Arial"/>
+              </a:defRPr>
+            </a:pPr>
+            <a:r>
+              <a:rPr sz="2700"/>
+              <a:t>Local versus global search: +0.116–0.123 visibility Gini under adaptive rewiring.</a:t>
+            </a:r>
+          </a:p>
+        </p:txBody>
+      </p:sp>
+      <p:sp>
+        <p:nvSpPr>
+          <p:cNvPr id="8" name="TextBox 7"/>
+          <p:cNvSpPr txBox="1"/>
+          <p:nvPr/>
+        </p:nvSpPr>
+        <p:spPr>
+          <a:xfrm>
+            <a:off x="914400" y="9070848"/>
+            <a:ext cx="16459200" cy="731520"/>
+          </a:xfrm>
+          <a:prstGeom prst="rect">
+            <a:avLst/>
+          </a:prstGeom>
+          <a:noFill/>
+        </p:spPr>
+        <p:txBody>
+          <a:bodyPr wrap="square" lIns="0" rIns="0" tIns="0" bIns="0">
+            <a:spAutoFit/>
+          </a:bodyPr>
+          <a:lstStyle/>
+          <a:p>
+            <a:pPr algn="l">
+              <a:spcAft>
+                <a:spcPts val="400"/>
+              </a:spcAft>
+              <a:defRPr sz="1900" b="0">
+                <a:solidFill>
+                  <a:srgbClr val="666666"/>
+                </a:solidFill>
+                <a:latin typeface="Arial"/>
+              </a:defRPr>
+            </a:pPr>
+            <a:r>
+              <a:rPr sz="1900"/>
+              <a:t>Matched random turnover produces a similar gap. All nine adaptive–matched extraction CIs include zero.</a:t>
+            </a:r>
+          </a:p>
+          <a:p>
+            <a:pPr algn="l">
+              <a:spcAft>
+                <a:spcPts val="400"/>
+              </a:spcAft>
+              <a:defRPr sz="1900" b="0">
+                <a:solidFill>
+                  <a:srgbClr val="666666"/>
+                </a:solidFill>
+                <a:latin typeface="Arial"/>
+              </a:defRPr>
+            </a:pPr>
+            <a:r>
+              <a:rPr sz="1900"/>
+              <a:t>100 replicates; final 1,000 training steps; pointwise 95% bootstrap CIs. “Local” means social-graph proximity.</a:t>
+            </a:r>
+          </a:p>
+        </p:txBody>
+      </p:sp>
       <p:pic>
         <p:nvPicPr>
-          <p:cNvPr id="6" name="Picture 5" descr="sustainability.png"/>
+          <p:cNvPr id="9" name="Picture 8" descr="organization.png"/>
           <p:cNvPicPr>
             <a:picLocks noChangeAspect="1"/>
           </p:cNvPicPr>
           <p:nvPr/>
         </p:nvPicPr>
         <p:blipFill>
-          <a:blip r:embed="rId2"/>
+          <a:blip r:embed="rId4"/>
           <a:stretch>
             <a:fillRect/>
           </a:stretch>
         </p:blipFill>
         <p:spPr>
           <a:xfrm>
-            <a:off x="594360" y="2669713"/>
-            <a:ext cx="16916400" cy="5313332"/>
+            <a:off x="457200" y="2377440"/>
+            <a:ext cx="17373600" cy="6190488"/>
           </a:xfrm>
           <a:prstGeom prst="rect">
             <a:avLst/>
           </a:prstGeom>
         </p:spPr>
       </p:pic>
-      <p:sp>
-        <p:nvSpPr>
-          <p:cNvPr id="7" name="TextBox 6"/>
-          <p:cNvSpPr txBox="1"/>
-          <p:nvPr/>
-        </p:nvSpPr>
-        <p:spPr>
-          <a:xfrm>
-            <a:off x="914400" y="8092440"/>
-            <a:ext cx="16459200" cy="594360"/>
-          </a:xfrm>
-          <a:prstGeom prst="rect">
-            <a:avLst/>
-          </a:prstGeom>
-          <a:noFill/>
-        </p:spPr>
-        <p:txBody>
-          <a:bodyPr wrap="square" lIns="0" rIns="0" tIns="0" bIns="0">
-            <a:spAutoFit/>
-          </a:bodyPr>
-          <a:lstStyle/>
-          <a:p>
-            <a:pPr algn="l">
-              <a:spcAft>
-                <a:spcPts val="400"/>
-              </a:spcAft>
-              <a:defRPr sz="2900" b="1">
-                <a:solidFill>
-                  <a:srgbClr val="111111"/>
-                </a:solidFill>
-                <a:latin typeface="Arial"/>
-              </a:defRPr>
-            </a:pPr>
-            <a:r>
-              <a:t>15 of 18 intervals cross zero; the direction also changes across conditions.</a:t>
-            </a:r>
-          </a:p>
-        </p:txBody>
-      </p:sp>
-      <p:sp>
-        <p:nvSpPr>
-          <p:cNvPr id="8" name="TextBox 7"/>
-          <p:cNvSpPr txBox="1"/>
-          <p:nvPr/>
-        </p:nvSpPr>
-        <p:spPr>
-          <a:xfrm>
-            <a:off x="914400" y="8833104"/>
-            <a:ext cx="16459200" cy="731520"/>
-          </a:xfrm>
-          <a:prstGeom prst="rect">
-            <a:avLst/>
-          </a:prstGeom>
-          <a:noFill/>
-        </p:spPr>
-        <p:txBody>
-          <a:bodyPr wrap="square" lIns="0" rIns="0" tIns="0" bIns="0">
-            <a:spAutoFit/>
-          </a:bodyPr>
-          <a:lstStyle/>
-          <a:p>
-            <a:pPr algn="l">
-              <a:spcAft>
-                <a:spcPts val="400"/>
-              </a:spcAft>
-              <a:defRPr sz="2000" b="0">
-                <a:solidFill>
-                  <a:srgbClr val="666666"/>
-                </a:solidFill>
-                <a:latin typeface="Arial"/>
-              </a:defRPr>
-            </a:pPr>
-            <a:r>
-              <a:t>Right of zero = more resource under adaptive rewiring. Rows show search scope and population.</a:t>
-            </a:r>
-          </a:p>
-          <a:p>
-            <a:pPr algn="l">
-              <a:spcAft>
-                <a:spcPts val="400"/>
-              </a:spcAft>
-              <a:defRPr sz="2000" b="0">
-                <a:solidFill>
-                  <a:srgbClr val="666666"/>
-                </a:solidFill>
-                <a:latin typeface="Arial"/>
-              </a:defRPr>
-            </a:pPr>
-            <a:r>
-              <a:t>10 paired replicates; 95% bootstrap intervals (2,000 resamples), exploratory and not multiplicity-adjusted.</a:t>
-            </a:r>
-          </a:p>
-        </p:txBody>
-      </p:sp>
     </p:spTree>
   </p:cSld>
   <p:clrMapOvr>
@@ -8031,7 +8058,7 @@
               <a:spcAft>
                 <a:spcPts val="400"/>
               </a:spcAft>
-              <a:defRPr sz="4050" b="1">
+              <a:defRPr sz="3800" b="1">
                 <a:solidFill>
                   <a:srgbClr val="111111"/>
                 </a:solidFill>
@@ -8039,7 +8066,8 @@
               </a:defRPr>
             </a:pPr>
             <a:r>
-              <a:t>A resource gain is not a complete welfare story</a:t>
+              <a:rPr sz="3800"/>
+              <a:t>Ecology changes welfare and inequality; adaptive benefits are inconsistent</a:t>
             </a:r>
           </a:p>
         </p:txBody>
@@ -8078,7 +8106,7 @@
               </a:defRPr>
             </a:pPr>
             <a:r>
-              <a:t>Closer look: split high / low ecology · all six adaptive-versus-R0 comparisons</a:t>
+              <a:t>Absolute outcomes · 1,000-step fresh-reset evaluation · frozen policies and terminal networks</a:t>
             </a:r>
           </a:p>
         </p:txBody>
@@ -8117,7 +8145,7 @@
               </a:defRPr>
             </a:pPr>
             <a:r>
-              <a:t>COGNITIVE TOOLS  /  SUPERVISOR DATA ROUND  /  PILOT v1</a:t>
+              <a:t>COGNITIVE TOOLS  /  SUPERVISOR DATA ROUND  /  FULL RUN · SEPTEMBER 2026</a:t>
             </a:r>
           </a:p>
         </p:txBody>
@@ -8161,124 +8189,127 @@
           </a:p>
         </p:txBody>
       </p:sp>
+      <p:sp>
+        <p:nvSpPr>
+          <p:cNvPr id="7" name="TextBox 6"/>
+          <p:cNvSpPr txBox="1"/>
+          <p:nvPr/>
+        </p:nvSpPr>
+        <p:spPr>
+          <a:xfrm>
+            <a:off x="914400" y="8458200"/>
+            <a:ext cx="16459200" cy="640080"/>
+          </a:xfrm>
+          <a:prstGeom prst="rect">
+            <a:avLst/>
+          </a:prstGeom>
+          <a:noFill/>
+        </p:spPr>
+        <p:txBody>
+          <a:bodyPr wrap="square" lIns="0" rIns="0" tIns="0" bIns="0">
+            <a:spAutoFit/>
+          </a:bodyPr>
+          <a:lstStyle/>
+          <a:p>
+            <a:pPr algn="l">
+              <a:spcAft>
+                <a:spcPts val="400"/>
+              </a:spcAft>
+              <a:defRPr sz="2700" b="1">
+                <a:solidFill>
+                  <a:srgbClr val="111111"/>
+                </a:solidFill>
+                <a:latin typeface="Arial"/>
+              </a:defRPr>
+            </a:pPr>
+            <a:r>
+              <a:rPr sz="2700"/>
+              <a:t>Split versus uniform: welfare −9.5 to −11.9 pp; wealth Gini +0.169 to +0.175.</a:t>
+            </a:r>
+          </a:p>
+        </p:txBody>
+      </p:sp>
+      <p:sp>
+        <p:nvSpPr>
+          <p:cNvPr id="8" name="TextBox 7"/>
+          <p:cNvSpPr txBox="1"/>
+          <p:nvPr/>
+        </p:nvSpPr>
+        <p:spPr>
+          <a:xfrm>
+            <a:off x="914400" y="9070848"/>
+            <a:ext cx="16459200" cy="822960"/>
+          </a:xfrm>
+          <a:prstGeom prst="rect">
+            <a:avLst/>
+          </a:prstGeom>
+          <a:noFill/>
+        </p:spPr>
+        <p:txBody>
+          <a:bodyPr wrap="square" lIns="0" rIns="0" tIns="0" bIns="0">
+            <a:spAutoFit/>
+          </a:bodyPr>
+          <a:lstStyle/>
+          <a:p>
+            <a:pPr algn="l">
+              <a:spcAft>
+                <a:spcPts val="400"/>
+              </a:spcAft>
+              <a:defRPr sz="1900" b="0">
+                <a:solidFill>
+                  <a:srgbClr val="666666"/>
+                </a:solidFill>
+                <a:latin typeface="Arial"/>
+              </a:defRPr>
+            </a:pPr>
+            <a:r>
+              <a:rPr sz="1900"/>
+              <a:t>Adaptive–matched welfare: only 1 of 9 pointwise CIs excludes zero. Split changes several ecological parameters together.</a:t>
+            </a:r>
+          </a:p>
+          <a:p>
+            <a:pPr algn="l">
+              <a:spcAft>
+                <a:spcPts val="400"/>
+              </a:spcAft>
+              <a:defRPr sz="1900" b="0">
+                <a:solidFill>
+                  <a:srgbClr val="666666"/>
+                </a:solidFill>
+                <a:latin typeface="Arial"/>
+              </a:defRPr>
+            </a:pPr>
+            <a:r>
+              <a:rPr sz="1900"/>
+              <a:t>Reset matters: mean reserve welfare is 72% after reset versus 26% in continuation. This is not long-run sustainability.</a:t>
+            </a:r>
+          </a:p>
+        </p:txBody>
+      </p:sp>
       <p:pic>
         <p:nvPicPr>
-          <p:cNvPr id="6" name="Picture 5" descr="split_tradeoffs.png"/>
+          <p:cNvPr id="9" name="Picture 8" descr="outcomes.png"/>
           <p:cNvPicPr>
             <a:picLocks noChangeAspect="1"/>
           </p:cNvPicPr>
           <p:nvPr/>
         </p:nvPicPr>
         <p:blipFill>
-          <a:blip r:embed="rId2"/>
+          <a:blip r:embed="rId4"/>
           <a:stretch>
             <a:fillRect/>
           </a:stretch>
         </p:blipFill>
         <p:spPr>
           <a:xfrm>
-            <a:off x="594360" y="2763355"/>
-            <a:ext cx="16916400" cy="4988888"/>
+            <a:off x="457200" y="2377440"/>
+            <a:ext cx="17373600" cy="6190488"/>
           </a:xfrm>
           <a:prstGeom prst="rect">
             <a:avLst/>
           </a:prstGeom>
         </p:spPr>
       </p:pic>
-      <p:sp>
-        <p:nvSpPr>
-          <p:cNvPr id="7" name="TextBox 6"/>
-          <p:cNvSpPr txBox="1"/>
-          <p:nvPr/>
-        </p:nvSpPr>
-        <p:spPr>
-          <a:xfrm>
-            <a:off x="914400" y="8001000"/>
-            <a:ext cx="16459200" cy="640080"/>
-          </a:xfrm>
-          <a:prstGeom prst="rect">
-            <a:avLst/>
-          </a:prstGeom>
-          <a:noFill/>
-        </p:spPr>
-        <p:txBody>
-          <a:bodyPr wrap="square" lIns="0" rIns="0" tIns="0" bIns="0">
-            <a:spAutoFit/>
-          </a:bodyPr>
-          <a:lstStyle/>
-          <a:p>
-            <a:pPr algn="l">
-              <a:spcAft>
-                <a:spcPts val="400"/>
-              </a:spcAft>
-              <a:defRPr sz="2900" b="1">
-                <a:solidFill>
-                  <a:srgbClr val="111111"/>
-                </a:solidFill>
-                <a:latin typeface="Arial"/>
-              </a:defRPr>
-            </a:pPr>
-            <a:r>
-              <a:t>Mixed search, N=64: resource +1.02 pp; reserve welfare +1.62 pp.</a:t>
-            </a:r>
-          </a:p>
-        </p:txBody>
-      </p:sp>
-      <p:sp>
-        <p:nvSpPr>
-          <p:cNvPr id="8" name="TextBox 7"/>
-          <p:cNvSpPr txBox="1"/>
-          <p:nvPr/>
-        </p:nvSpPr>
-        <p:spPr>
-          <a:xfrm>
-            <a:off x="914400" y="8677656"/>
-            <a:ext cx="16459200" cy="822960"/>
-          </a:xfrm>
-          <a:prstGeom prst="rect">
-            <a:avLst/>
-          </a:prstGeom>
-          <a:noFill/>
-        </p:spPr>
-        <p:txBody>
-          <a:bodyPr wrap="square" lIns="0" rIns="0" tIns="0" bIns="0">
-            <a:spAutoFit/>
-          </a:bodyPr>
-          <a:lstStyle/>
-          <a:p>
-            <a:pPr algn="l">
-              <a:spcAft>
-                <a:spcPts val="400"/>
-              </a:spcAft>
-              <a:defRPr sz="2000" b="0">
-                <a:solidFill>
-                  <a:srgbClr val="666666"/>
-                </a:solidFill>
-                <a:latin typeface="Arial"/>
-              </a:defRPr>
-            </a:pPr>
-            <a:r>
-              <a:t>Its wealth-inequality interval crosses zero. More resource does not establish a fairer outcome.</a:t>
-            </a:r>
-          </a:p>
-          <a:p>
-            <a:pPr algn="l">
-              <a:spcAft>
-                <a:spcPts val="400"/>
-              </a:spcAft>
-              <a:defRPr sz="2000" b="0">
-                <a:solidFill>
-                  <a:srgbClr val="666666"/>
-                </a:solidFill>
-                <a:latin typeface="Arial"/>
-              </a:defRPr>
-            </a:pPr>
-            <a:r>
-              <a:t>Positive = more resource / welfare, but more inequality. Same 10 pairs and 95% bootstrap method as slide 5.</a:t>
-            </a:r>
-          </a:p>
-        </p:txBody>
-      </p:sp>
     </p:spTree>
   </p:cSld>
   <p:clrMapOvr>
@@ -8331,7 +8362,7 @@
               <a:spcAft>
                 <a:spcPts val="400"/>
               </a:spcAft>
-              <a:defRPr sz="4050" b="1">
+              <a:defRPr sz="3800" b="1">
                 <a:solidFill>
                   <a:srgbClr val="111111"/>
                 </a:solidFill>
@@ -8339,7 +8370,8 @@
               </a:defRPr>
             </a:pPr>
             <a:r>
-              <a:t>The project can stay focused on one micro-to-macro test</a:t>
+              <a:rPr sz="3800"/>
+              <a:t>The next question is when information becomes useful for decisions</a:t>
             </a:r>
           </a:p>
         </p:txBody>
@@ -8378,7 +8410,7 @@
               </a:defRPr>
             </a:pPr>
             <a:r>
-              <a:t>Individual observation → population patterns → sustainability, welfare, and inequality</a:t>
+              <a:t>Completed study: ecology → population perception and organization → material consequences</a:t>
             </a:r>
           </a:p>
         </p:txBody>
@@ -8417,7 +8449,7 @@
               </a:defRPr>
             </a:pPr>
             <a:r>
-              <a:t>COGNITIVE TOOLS  /  SUPERVISOR DATA ROUND  /  PILOT v1</a:t>
+              <a:t>COGNITIVE TOOLS  /  SUPERVISOR DATA ROUND  /  FULL RUN · SEPTEMBER 2026</a:t>
             </a:r>
           </a:p>
         </p:txBody>
@@ -8575,7 +8607,7 @@
               <a:spcAft>
                 <a:spcPts val="400"/>
               </a:spcAft>
-              <a:defRPr sz="3000" b="1">
+              <a:defRPr sz="2600" b="1">
                 <a:solidFill>
                   <a:srgbClr val="111111"/>
                 </a:solidFill>
@@ -8583,7 +8615,8 @@
               </a:defRPr>
             </a:pPr>
             <a:r>
-              <a:t>What the pilot shows</a:t>
+              <a:rPr sz="2600"/>
+              <a:t>What the run establishes</a:t>
             </a:r>
           </a:p>
         </p:txBody>
@@ -8622,7 +8655,7 @@
               </a:defRPr>
             </a:pPr>
             <a:r>
-              <a:t>Local search changes</a:t>
+              <a:t>Observation rules shift</a:t>
             </a:r>
           </a:p>
           <a:p>
@@ -8638,7 +8671,7 @@
               </a:defRPr>
             </a:pPr>
             <a:r>
-              <a:t>who becomes visible.</a:t>
+              <a:t>perception and concentration.</a:t>
             </a:r>
           </a:p>
           <a:p>
@@ -8667,7 +8700,7 @@
               </a:defRPr>
             </a:pPr>
             <a:r>
-              <a:t>Random turnover can produce</a:t>
+              <a:t>Ecology shifts welfare</a:t>
             </a:r>
           </a:p>
           <a:p>
@@ -8683,7 +8716,7 @@
               </a:defRPr>
             </a:pPr>
             <a:r>
-              <a:t>a similar concentration.</a:t>
+              <a:t>and wealth inequality.</a:t>
             </a:r>
           </a:p>
         </p:txBody>
@@ -8802,7 +8835,7 @@
               <a:spcAft>
                 <a:spcPts val="400"/>
               </a:spcAft>
-              <a:defRPr sz="3000" b="1">
+              <a:defRPr sz="2600" b="1">
                 <a:solidFill>
                   <a:srgbClr val="111111"/>
                 </a:solidFill>
@@ -8810,6 +8843,7 @@
               </a:defRPr>
             </a:pPr>
             <a:r>
+              <a:rPr sz="2600"/>
               <a:t>What remains unresolved</a:t>
             </a:r>
           </a:p>
@@ -8849,7 +8883,7 @@
               </a:defRPr>
             </a:pPr>
             <a:r>
-              <a:t>Does the error trigger create</a:t>
+              <a:t>Better population estimates</a:t>
             </a:r>
           </a:p>
           <a:p>
@@ -8865,7 +8899,7 @@
               </a:defRPr>
             </a:pPr>
             <a:r>
-              <a:t>a distinct collective pattern?</a:t>
+              <a:t>do not consistently improve</a:t>
             </a:r>
           </a:p>
           <a:p>
@@ -8894,7 +8928,7 @@
               </a:defRPr>
             </a:pPr>
             <a:r>
-              <a:t>Does that pattern improve</a:t>
+              <a:t>local decisions or welfare.</a:t>
             </a:r>
           </a:p>
           <a:p>
@@ -8910,7 +8944,7 @@
               </a:defRPr>
             </a:pPr>
             <a:r>
-              <a:t>resource outcomes?</a:t>
+              <a:t>The causal link is untested.</a:t>
             </a:r>
           </a:p>
         </p:txBody>
@@ -9029,7 +9063,7 @@
               <a:spcAft>
                 <a:spcPts val="400"/>
               </a:spcAft>
-              <a:defRPr sz="3000" b="1">
+              <a:defRPr sz="2600" b="1">
                 <a:solidFill>
                   <a:srgbClr val="111111"/>
                 </a:solidFill>
@@ -9037,7 +9071,8 @@
               </a:defRPr>
             </a:pPr>
             <a:r>
-              <a:t>What the next test needs</a:t>
+              <a:rPr sz="2600"/>
+              <a:t>One bounded next study</a:t>
             </a:r>
           </a:p>
         </p:txBody>
@@ -9076,7 +9111,7 @@
               </a:defRPr>
             </a:pPr>
             <a:r>
-              <a:t>Specify the expected</a:t>
+              <a:t>One Harvest environment;</a:t>
             </a:r>
           </a:p>
           <a:p>
@@ -9092,7 +9127,7 @@
               </a:defRPr>
             </a:pPr>
             <a:r>
-              <a:t>population pattern.</a:t>
+              <a:t>fixed learner and attention.</a:t>
             </a:r>
           </a:p>
           <a:p>
@@ -9121,7 +9156,7 @@
               </a:defRPr>
             </a:pPr>
             <a:r>
-              <a:t>Keep matched R0 and</a:t>
+              <a:t>Informative versus shuffled</a:t>
             </a:r>
           </a:p>
           <a:p>
@@ -9137,7 +9172,7 @@
               </a:defRPr>
             </a:pPr>
             <a:r>
-              <a:t>replicate-level uncertainty.</a:t>
+              <a:t>signals; matched productivity.</a:t>
             </a:r>
           </a:p>
         </p:txBody>
@@ -9207,7 +9242,7 @@
               <a:spcAft>
                 <a:spcPts val="400"/>
               </a:spcAft>
-              <a:defRPr sz="2900" b="0">
+              <a:defRPr sz="2500" b="0">
                 <a:solidFill>
                   <a:srgbClr val="111111"/>
                 </a:solidFill>
@@ -9215,7 +9250,8 @@
               </a:defRPr>
             </a:pPr>
             <a:r>
-              <a:t>Is the question narrow enough?</a:t>
+              <a:rPr sz="2500"/>
+              <a:t>Are RQ1 and RQ2 clear, and do these measures capture collective organization?</a:t>
             </a:r>
           </a:p>
           <a:p>
@@ -9223,7 +9259,7 @@
               <a:spcAft>
                 <a:spcPts val="400"/>
               </a:spcAft>
-              <a:defRPr sz="2900" b="0">
+              <a:defRPr sz="2500" b="0">
                 <a:solidFill>
                   <a:srgbClr val="111111"/>
                 </a:solidFill>
@@ -9231,7 +9267,8 @@
               </a:defRPr>
             </a:pPr>
             <a:r>
-              <a:t>Is “collective organization” defined clearly enough to test?</a:t>
+              <a:rPr sz="2500"/>
+              <a:t>Should the next hypothesis target decision usefulness rather than global accuracy?</a:t>
             </a:r>
           </a:p>
           <a:p>
@@ -9239,7 +9276,7 @@
               <a:spcAft>
                 <a:spcPts val="400"/>
               </a:spcAft>
-              <a:defRPr sz="2900" b="0">
+              <a:defRPr sz="2500" b="0">
                 <a:solidFill>
                   <a:srgbClr val="111111"/>
                 </a:solidFill>
@@ -9247,7 +9284,8 @@
               </a:defRPr>
             </a:pPr>
             <a:r>
-              <a:t>Which link in the mechanism needs the strongest evidence?</a:t>
+              <a:rPr sz="2500"/>
+              <a:t>Would SocialJax Commons Harvest justify migration, or should we retain this model?</a:t>
             </a:r>
           </a:p>
         </p:txBody>

</xml_diff>